<commit_message>
Add game screenshots and embed them in the presentation
Captured 4 real screenshots of the game (language, levels, quiz, result)
with Playwright/Chromium and embedded them into the slides:
- Slide "Présentation" : language screen
- Slide "Les écrans" : 2x2 grid of the four screens
- Slide "Démonstration" : large quiz screenshot

Co-Authored-By: Claude Opus 4.8 <noreply@anthropic.com>
Claude-Session: https://claude.ai/code/session_014yuHwbWoTnAJdtDhfAkid4
</commit_message>
<xml_diff>
--- a/quiz-game/Presentation_ISMAGI_Quiz_Game.pptx
+++ b/quiz-game/Presentation_ISMAGI_Quiz_Game.pptx
@@ -3239,8 +3239,8 @@
         </p:nvSpPr>
         <p:spPr>
           <a:xfrm>
-            <a:off x="914400" y="1737360"/>
-            <a:ext cx="10332720" cy="548640"/>
+            <a:off x="914400" y="1691640"/>
+            <a:ext cx="10332720" cy="640080"/>
           </a:xfrm>
           <a:prstGeom prst="rect">
             <a:avLst/>
@@ -3255,7 +3255,7 @@
           <a:p>
             <a:pPr algn="ctr"/>
             <a:r>
-              <a:rPr sz="4600" b="0" i="0">
+              <a:rPr sz="4400" b="0" i="0">
                 <a:solidFill>
                   <a:srgbClr val="ECEEF8"/>
                 </a:solidFill>
@@ -3274,7 +3274,7 @@
         </p:nvSpPr>
         <p:spPr>
           <a:xfrm>
-            <a:off x="731520" y="2468880"/>
+            <a:off x="731520" y="2423160"/>
             <a:ext cx="10698480" cy="1463040"/>
           </a:xfrm>
           <a:prstGeom prst="rect">
@@ -3330,7 +3330,7 @@
         </p:nvSpPr>
         <p:spPr>
           <a:xfrm>
-            <a:off x="3108960" y="4480560"/>
+            <a:off x="3108960" y="4526280"/>
             <a:ext cx="5943600" cy="1554480"/>
           </a:xfrm>
           <a:prstGeom prst="rect">
@@ -3374,7 +3374,7 @@
         </p:nvSpPr>
         <p:spPr>
           <a:xfrm>
-            <a:off x="3291840" y="4617720"/>
+            <a:off x="3291840" y="4663440"/>
             <a:ext cx="5577840" cy="1371600"/>
           </a:xfrm>
           <a:prstGeom prst="rect">
@@ -3539,7 +3539,7 @@
         <p:spPr>
           <a:xfrm>
             <a:off x="868680" y="457200"/>
-            <a:ext cx="10607040" cy="914400"/>
+            <a:ext cx="10789920" cy="914400"/>
           </a:xfrm>
           <a:prstGeom prst="rect">
             <a:avLst/>
@@ -3572,7 +3572,7 @@
         </p:nvSpPr>
         <p:spPr>
           <a:xfrm>
-            <a:off x="960120" y="1691640"/>
+            <a:off x="960120" y="1737360"/>
             <a:ext cx="10332720" cy="4480560"/>
           </a:xfrm>
           <a:prstGeom prst="rect">
@@ -3766,7 +3766,7 @@
         <p:spPr>
           <a:xfrm>
             <a:off x="457200" y="6400800"/>
-            <a:ext cx="11247120" cy="365760"/>
+            <a:ext cx="7315200" cy="365760"/>
           </a:xfrm>
           <a:prstGeom prst="rect">
             <a:avLst/>
@@ -3779,7 +3779,6 @@
           </a:bodyPr>
           <a:lstStyle/>
           <a:p>
-            <a:pPr algn="l"/>
             <a:r>
               <a:rPr sz="1000" b="0" i="0">
                 <a:solidFill>
@@ -3800,8 +3799,8 @@
         </p:nvSpPr>
         <p:spPr>
           <a:xfrm>
-            <a:off x="9418320" y="6400800"/>
-            <a:ext cx="2286000" cy="365760"/>
+            <a:off x="8229600" y="6400800"/>
+            <a:ext cx="3474720" cy="365760"/>
           </a:xfrm>
           <a:prstGeom prst="rect">
             <a:avLst/>
@@ -3861,8 +3860,8 @@
         </p:nvSpPr>
         <p:spPr>
           <a:xfrm>
-            <a:off x="914400" y="2468880"/>
-            <a:ext cx="10332720" cy="1828800"/>
+            <a:off x="914400" y="502920"/>
+            <a:ext cx="10332720" cy="822960"/>
           </a:xfrm>
           <a:prstGeom prst="rect">
             <a:avLst/>
@@ -3877,55 +3876,57 @@
           <a:p>
             <a:pPr algn="ctr"/>
             <a:r>
-              <a:rPr sz="4400" b="0" i="0">
-                <a:solidFill>
-                  <a:srgbClr val="ECEEF8"/>
-                </a:solidFill>
-                <a:latin typeface="Calibri"/>
-              </a:rPr>
-              <a:t>🎮</a:t>
-            </a:r>
-          </a:p>
-          <a:p>
-            <a:pPr algn="ctr"/>
-            <a:r>
-              <a:rPr sz="4400" b="1" i="0">
+              <a:rPr sz="3400" b="1" i="0">
                 <a:solidFill>
                   <a:srgbClr val="A78BFA"/>
                 </a:solidFill>
                 <a:latin typeface="Calibri"/>
               </a:rPr>
-              <a:t>Démonstration</a:t>
-            </a:r>
-          </a:p>
-          <a:p>
-            <a:pPr algn="ctr">
-              <a:spcBef>
-                <a:spcPts val="1000"/>
-              </a:spcBef>
-            </a:pPr>
-            <a:r>
-              <a:rPr sz="1800" b="0" i="1">
-                <a:solidFill>
-                  <a:srgbClr val="9AA0C8"/>
-                </a:solidFill>
-                <a:latin typeface="Calibri"/>
-              </a:rPr>
-              <a:t>Place à une démonstration en direct de l'application.</a:t>
-            </a:r>
-          </a:p>
-        </p:txBody>
-      </p:sp>
-      <p:sp>
-        <p:nvSpPr>
-          <p:cNvPr id="3" name="TextBox 2"/>
+              <a:t>🎮  Démonstration</a:t>
+            </a:r>
+          </a:p>
+        </p:txBody>
+      </p:sp>
+      <p:pic>
+        <p:nvPicPr>
+          <p:cNvPr id="3" name="Picture 2" descr="3-quiz.png"/>
+          <p:cNvPicPr>
+            <a:picLocks noChangeAspect="1"/>
+          </p:cNvPicPr>
+          <p:nvPr/>
+        </p:nvPicPr>
+        <p:blipFill>
+          <a:blip r:embed="rId2"/>
+          <a:stretch>
+            <a:fillRect/>
+          </a:stretch>
+        </p:blipFill>
+        <p:spPr>
+          <a:xfrm>
+            <a:off x="3072384" y="1554480"/>
+            <a:ext cx="6035040" cy="3922776"/>
+          </a:xfrm>
+          <a:prstGeom prst="rect">
+            <a:avLst/>
+          </a:prstGeom>
+          <a:ln w="19050">
+            <a:solidFill>
+              <a:srgbClr val="3A336B"/>
+            </a:solidFill>
+          </a:ln>
+          <a:effectLst/>
+        </p:spPr>
+      </p:pic>
+      <p:sp>
+        <p:nvSpPr>
+          <p:cNvPr id="4" name="TextBox 3"/>
           <p:cNvSpPr txBox="1"/>
           <p:nvPr/>
         </p:nvSpPr>
         <p:spPr>
           <a:xfrm>
-            <a:off x="457200" y="6400800"/>
-            <a:ext cx="11247120" cy="365760"/>
+            <a:off x="914400" y="6172200"/>
+            <a:ext cx="10332720" cy="457200"/>
           </a:xfrm>
           <a:prstGeom prst="rect">
             <a:avLst/>
@@ -3938,50 +3939,15 @@
           </a:bodyPr>
           <a:lstStyle/>
           <a:p>
-            <a:pPr algn="l"/>
-            <a:r>
-              <a:rPr sz="1000" b="0" i="0">
+            <a:pPr algn="ctr"/>
+            <a:r>
+              <a:rPr sz="1600" b="0" i="1">
                 <a:solidFill>
                   <a:srgbClr val="9AA0C8"/>
                 </a:solidFill>
                 <a:latin typeface="Calibri"/>
               </a:rPr>
-              <a:t>ISMAGI Quiz Game</a:t>
-            </a:r>
-          </a:p>
-        </p:txBody>
-      </p:sp>
-      <p:sp>
-        <p:nvSpPr>
-          <p:cNvPr id="4" name="TextBox 3"/>
-          <p:cNvSpPr txBox="1"/>
-          <p:nvPr/>
-        </p:nvSpPr>
-        <p:spPr>
-          <a:xfrm>
-            <a:off x="9418320" y="6400800"/>
-            <a:ext cx="2286000" cy="365760"/>
-          </a:xfrm>
-          <a:prstGeom prst="rect">
-            <a:avLst/>
-          </a:prstGeom>
-          <a:noFill/>
-        </p:spPr>
-        <p:txBody>
-          <a:bodyPr wrap="square">
-            <a:spAutoFit/>
-          </a:bodyPr>
-          <a:lstStyle/>
-          <a:p>
-            <a:pPr algn="r"/>
-            <a:r>
-              <a:rPr sz="1000" b="0" i="0">
-                <a:solidFill>
-                  <a:srgbClr val="9AA0C8"/>
-                </a:solidFill>
-                <a:latin typeface="Calibri"/>
-              </a:rPr>
-              <a:t>CP1 · 2025-2026</a:t>
+              <a:t>Place à une démonstration en direct de l'application.</a:t>
             </a:r>
           </a:p>
         </p:txBody>
@@ -4065,7 +4031,7 @@
         <p:spPr>
           <a:xfrm>
             <a:off x="868680" y="457200"/>
-            <a:ext cx="10607040" cy="914400"/>
+            <a:ext cx="10789920" cy="914400"/>
           </a:xfrm>
           <a:prstGeom prst="rect">
             <a:avLst/>
@@ -4098,7 +4064,7 @@
         </p:nvSpPr>
         <p:spPr>
           <a:xfrm>
-            <a:off x="960120" y="1691640"/>
+            <a:off x="960120" y="1737360"/>
             <a:ext cx="10332720" cy="4480560"/>
           </a:xfrm>
           <a:prstGeom prst="rect">
@@ -4231,7 +4197,7 @@
         <p:spPr>
           <a:xfrm>
             <a:off x="457200" y="6400800"/>
-            <a:ext cx="11247120" cy="365760"/>
+            <a:ext cx="7315200" cy="365760"/>
           </a:xfrm>
           <a:prstGeom prst="rect">
             <a:avLst/>
@@ -4244,7 +4210,6 @@
           </a:bodyPr>
           <a:lstStyle/>
           <a:p>
-            <a:pPr algn="l"/>
             <a:r>
               <a:rPr sz="1000" b="0" i="0">
                 <a:solidFill>
@@ -4265,8 +4230,8 @@
         </p:nvSpPr>
         <p:spPr>
           <a:xfrm>
-            <a:off x="9418320" y="6400800"/>
-            <a:ext cx="2286000" cy="365760"/>
+            <a:off x="8229600" y="6400800"/>
+            <a:ext cx="3474720" cy="365760"/>
           </a:xfrm>
           <a:prstGeom prst="rect">
             <a:avLst/>
@@ -4552,7 +4517,7 @@
         <p:spPr>
           <a:xfrm>
             <a:off x="868680" y="457200"/>
-            <a:ext cx="10607040" cy="914400"/>
+            <a:ext cx="10789920" cy="914400"/>
           </a:xfrm>
           <a:prstGeom prst="rect">
             <a:avLst/>
@@ -4585,7 +4550,7 @@
         </p:nvSpPr>
         <p:spPr>
           <a:xfrm>
-            <a:off x="960120" y="1691640"/>
+            <a:off x="960120" y="1737360"/>
             <a:ext cx="10332720" cy="4480560"/>
           </a:xfrm>
           <a:prstGeom prst="rect">
@@ -4809,7 +4774,7 @@
         <p:spPr>
           <a:xfrm>
             <a:off x="457200" y="6400800"/>
-            <a:ext cx="11247120" cy="365760"/>
+            <a:ext cx="7315200" cy="365760"/>
           </a:xfrm>
           <a:prstGeom prst="rect">
             <a:avLst/>
@@ -4822,7 +4787,6 @@
           </a:bodyPr>
           <a:lstStyle/>
           <a:p>
-            <a:pPr algn="l"/>
             <a:r>
               <a:rPr sz="1000" b="0" i="0">
                 <a:solidFill>
@@ -4843,8 +4807,8 @@
         </p:nvSpPr>
         <p:spPr>
           <a:xfrm>
-            <a:off x="9418320" y="6400800"/>
-            <a:ext cx="2286000" cy="365760"/>
+            <a:off x="8229600" y="6400800"/>
+            <a:ext cx="3474720" cy="365760"/>
           </a:xfrm>
           <a:prstGeom prst="rect">
             <a:avLst/>
@@ -4949,7 +4913,7 @@
         <p:spPr>
           <a:xfrm>
             <a:off x="868680" y="457200"/>
-            <a:ext cx="10607040" cy="914400"/>
+            <a:ext cx="10789920" cy="914400"/>
           </a:xfrm>
           <a:prstGeom prst="rect">
             <a:avLst/>
@@ -4982,7 +4946,7 @@
         </p:nvSpPr>
         <p:spPr>
           <a:xfrm>
-            <a:off x="960120" y="1691640"/>
+            <a:off x="960120" y="1737360"/>
             <a:ext cx="10332720" cy="4480560"/>
           </a:xfrm>
           <a:prstGeom prst="rect">
@@ -5124,7 +5088,7 @@
         <p:spPr>
           <a:xfrm>
             <a:off x="457200" y="6400800"/>
-            <a:ext cx="11247120" cy="365760"/>
+            <a:ext cx="7315200" cy="365760"/>
           </a:xfrm>
           <a:prstGeom prst="rect">
             <a:avLst/>
@@ -5137,7 +5101,6 @@
           </a:bodyPr>
           <a:lstStyle/>
           <a:p>
-            <a:pPr algn="l"/>
             <a:r>
               <a:rPr sz="1000" b="0" i="0">
                 <a:solidFill>
@@ -5158,8 +5121,8 @@
         </p:nvSpPr>
         <p:spPr>
           <a:xfrm>
-            <a:off x="9418320" y="6400800"/>
-            <a:ext cx="2286000" cy="365760"/>
+            <a:off x="8229600" y="6400800"/>
+            <a:ext cx="3474720" cy="365760"/>
           </a:xfrm>
           <a:prstGeom prst="rect">
             <a:avLst/>
@@ -5264,7 +5227,7 @@
         <p:spPr>
           <a:xfrm>
             <a:off x="868680" y="457200"/>
-            <a:ext cx="10607040" cy="914400"/>
+            <a:ext cx="10789920" cy="914400"/>
           </a:xfrm>
           <a:prstGeom prst="rect">
             <a:avLst/>
@@ -5297,7 +5260,7 @@
         </p:nvSpPr>
         <p:spPr>
           <a:xfrm>
-            <a:off x="960120" y="1691640"/>
+            <a:off x="960120" y="1737360"/>
             <a:ext cx="10332720" cy="4480560"/>
           </a:xfrm>
           <a:prstGeom prst="rect">
@@ -5446,7 +5409,7 @@
         <p:spPr>
           <a:xfrm>
             <a:off x="457200" y="6400800"/>
-            <a:ext cx="11247120" cy="365760"/>
+            <a:ext cx="7315200" cy="365760"/>
           </a:xfrm>
           <a:prstGeom prst="rect">
             <a:avLst/>
@@ -5459,7 +5422,6 @@
           </a:bodyPr>
           <a:lstStyle/>
           <a:p>
-            <a:pPr algn="l"/>
             <a:r>
               <a:rPr sz="1000" b="0" i="0">
                 <a:solidFill>
@@ -5480,8 +5442,8 @@
         </p:nvSpPr>
         <p:spPr>
           <a:xfrm>
-            <a:off x="9418320" y="6400800"/>
-            <a:ext cx="2286000" cy="365760"/>
+            <a:off x="8229600" y="6400800"/>
+            <a:ext cx="3474720" cy="365760"/>
           </a:xfrm>
           <a:prstGeom prst="rect">
             <a:avLst/>
@@ -5586,7 +5548,7 @@
         <p:spPr>
           <a:xfrm>
             <a:off x="868680" y="457200"/>
-            <a:ext cx="10607040" cy="914400"/>
+            <a:ext cx="10789920" cy="914400"/>
           </a:xfrm>
           <a:prstGeom prst="rect">
             <a:avLst/>
@@ -5619,8 +5581,8 @@
         </p:nvSpPr>
         <p:spPr>
           <a:xfrm>
-            <a:off x="960120" y="1691640"/>
-            <a:ext cx="10332720" cy="4480560"/>
+            <a:off x="868680" y="1828800"/>
+            <a:ext cx="5212080" cy="4389120"/>
           </a:xfrm>
           <a:prstGeom prst="rect">
             <a:avLst/>
@@ -5635,11 +5597,11 @@
           <a:p>
             <a:pPr>
               <a:spcAft>
-                <a:spcPts val="1300"/>
+                <a:spcPts val="1400"/>
               </a:spcAft>
             </a:pPr>
             <a:r>
-              <a:rPr sz="2000" b="1" i="0">
+              <a:rPr sz="1800" b="1" i="0">
                 <a:solidFill>
                   <a:srgbClr val="A78BFA"/>
                 </a:solidFill>
@@ -5648,23 +5610,23 @@
               <a:t>▸  </a:t>
             </a:r>
             <a:r>
-              <a:rPr sz="1900" b="0" i="0">
+              <a:rPr sz="1800" b="0" i="0">
                 <a:solidFill>
                   <a:srgbClr val="ECEEF8"/>
                 </a:solidFill>
                 <a:latin typeface="Calibri"/>
               </a:rPr>
-              <a:t>Un jeu de questions-réponses (QCM) portant sur l'ISMAGI.</a:t>
+              <a:t>Un jeu de questions-réponses (QCM) sur l'ISMAGI.</a:t>
             </a:r>
           </a:p>
           <a:p>
             <a:pPr>
               <a:spcAft>
-                <a:spcPts val="1300"/>
+                <a:spcPts val="1400"/>
               </a:spcAft>
             </a:pPr>
             <a:r>
-              <a:rPr sz="2000" b="1" i="0">
+              <a:rPr sz="1800" b="1" i="0">
                 <a:solidFill>
                   <a:srgbClr val="A78BFA"/>
                 </a:solidFill>
@@ -5673,32 +5635,23 @@
               <a:t>▸  </a:t>
             </a:r>
             <a:r>
-              <a:rPr sz="1900" b="1" i="0">
+              <a:rPr sz="1800" b="0" i="0">
                 <a:solidFill>
                   <a:srgbClr val="ECEEF8"/>
                 </a:solidFill>
                 <a:latin typeface="Calibri"/>
               </a:rPr>
-              <a:t>Déroulement : </a:t>
-            </a:r>
-            <a:r>
-              <a:rPr sz="1900" b="0" i="0">
-                <a:solidFill>
-                  <a:srgbClr val="9AA0C8"/>
-                </a:solidFill>
-                <a:latin typeface="Calibri"/>
-              </a:rPr>
-              <a:t>choisir la langue → saisir le nom → choisir un niveau → répondre.</a:t>
+              <a:t>Parcours : langue → nom → niveau → questions.</a:t>
             </a:r>
           </a:p>
           <a:p>
             <a:pPr>
               <a:spcAft>
-                <a:spcPts val="1300"/>
+                <a:spcPts val="1400"/>
               </a:spcAft>
             </a:pPr>
             <a:r>
-              <a:rPr sz="2000" b="1" i="0">
+              <a:rPr sz="1800" b="1" i="0">
                 <a:solidFill>
                   <a:srgbClr val="A78BFA"/>
                 </a:solidFill>
@@ -5707,32 +5660,23 @@
               <a:t>▸  </a:t>
             </a:r>
             <a:r>
-              <a:rPr sz="1900" b="1" i="0">
+              <a:rPr sz="1800" b="0" i="0">
                 <a:solidFill>
                   <a:srgbClr val="ECEEF8"/>
                 </a:solidFill>
                 <a:latin typeface="Calibri"/>
               </a:rPr>
-              <a:t>3 niveaux de difficulté : </a:t>
-            </a:r>
-            <a:r>
-              <a:rPr sz="1900" b="0" i="0">
-                <a:solidFill>
-                  <a:srgbClr val="9AA0C8"/>
-                </a:solidFill>
-                <a:latin typeface="Calibri"/>
-              </a:rPr>
-              <a:t>Facile, Moyen et Difficile.</a:t>
+              <a:t>3 niveaux : Facile, Moyen, Difficile.</a:t>
             </a:r>
           </a:p>
           <a:p>
             <a:pPr>
               <a:spcAft>
-                <a:spcPts val="1300"/>
+                <a:spcPts val="1400"/>
               </a:spcAft>
             </a:pPr>
             <a:r>
-              <a:rPr sz="2000" b="1" i="0">
+              <a:rPr sz="1800" b="1" i="0">
                 <a:solidFill>
                   <a:srgbClr val="A78BFA"/>
                 </a:solidFill>
@@ -5741,23 +5685,23 @@
               <a:t>▸  </a:t>
             </a:r>
             <a:r>
-              <a:rPr sz="1900" b="0" i="0">
+              <a:rPr sz="1800" b="0" i="0">
                 <a:solidFill>
                   <a:srgbClr val="ECEEF8"/>
                 </a:solidFill>
                 <a:latin typeface="Calibri"/>
               </a:rPr>
-              <a:t>3 questions par niveau, avec 4 réponses possibles (A, B, C, D).</a:t>
+              <a:t>3 questions par niveau, 4 réponses (A-D).</a:t>
             </a:r>
           </a:p>
           <a:p>
             <a:pPr>
               <a:spcAft>
-                <a:spcPts val="1300"/>
+                <a:spcPts val="1400"/>
               </a:spcAft>
             </a:pPr>
             <a:r>
-              <a:rPr sz="2000" b="1" i="0">
+              <a:rPr sz="1800" b="1" i="0">
                 <a:solidFill>
                   <a:srgbClr val="A78BFA"/>
                 </a:solidFill>
@@ -5766,36 +5710,57 @@
               <a:t>▸  </a:t>
             </a:r>
             <a:r>
-              <a:rPr sz="1900" b="1" i="0">
+              <a:rPr sz="1800" b="0" i="0">
                 <a:solidFill>
                   <a:srgbClr val="ECEEF8"/>
                 </a:solidFill>
                 <a:latin typeface="Calibri"/>
               </a:rPr>
-              <a:t>Écran de résultat : </a:t>
-            </a:r>
-            <a:r>
-              <a:rPr sz="1900" b="0" i="0">
-                <a:solidFill>
-                  <a:srgbClr val="9AA0C8"/>
-                </a:solidFill>
-                <a:latin typeface="Calibri"/>
-              </a:rPr>
-              <a:t>score, étoiles et message d'encouragement.</a:t>
-            </a:r>
-          </a:p>
-        </p:txBody>
-      </p:sp>
-      <p:sp>
-        <p:nvSpPr>
-          <p:cNvPr id="5" name="TextBox 4"/>
+              <a:t>Écran de résultat : score, étoiles, message.</a:t>
+            </a:r>
+          </a:p>
+        </p:txBody>
+      </p:sp>
+      <p:pic>
+        <p:nvPicPr>
+          <p:cNvPr id="5" name="Picture 4" descr="1-langue.png"/>
+          <p:cNvPicPr>
+            <a:picLocks noChangeAspect="1"/>
+          </p:cNvPicPr>
+          <p:nvPr/>
+        </p:nvPicPr>
+        <p:blipFill>
+          <a:blip r:embed="rId2"/>
+          <a:stretch>
+            <a:fillRect/>
+          </a:stretch>
+        </p:blipFill>
+        <p:spPr>
+          <a:xfrm>
+            <a:off x="6400800" y="1737360"/>
+            <a:ext cx="5212080" cy="3387852"/>
+          </a:xfrm>
+          <a:prstGeom prst="rect">
+            <a:avLst/>
+          </a:prstGeom>
+          <a:ln w="19050">
+            <a:solidFill>
+              <a:srgbClr val="3A336B"/>
+            </a:solidFill>
+          </a:ln>
+          <a:effectLst/>
+        </p:spPr>
+      </p:pic>
+      <p:sp>
+        <p:nvSpPr>
+          <p:cNvPr id="6" name="TextBox 5"/>
           <p:cNvSpPr txBox="1"/>
           <p:nvPr/>
         </p:nvSpPr>
         <p:spPr>
           <a:xfrm>
             <a:off x="457200" y="6400800"/>
-            <a:ext cx="11247120" cy="365760"/>
+            <a:ext cx="7315200" cy="365760"/>
           </a:xfrm>
           <a:prstGeom prst="rect">
             <a:avLst/>
@@ -5808,7 +5773,6 @@
           </a:bodyPr>
           <a:lstStyle/>
           <a:p>
-            <a:pPr algn="l"/>
             <a:r>
               <a:rPr sz="1000" b="0" i="0">
                 <a:solidFill>
@@ -5823,14 +5787,14 @@
       </p:sp>
       <p:sp>
         <p:nvSpPr>
-          <p:cNvPr id="6" name="TextBox 5"/>
+          <p:cNvPr id="7" name="TextBox 6"/>
           <p:cNvSpPr txBox="1"/>
           <p:nvPr/>
         </p:nvSpPr>
         <p:spPr>
           <a:xfrm>
-            <a:off x="9418320" y="6400800"/>
-            <a:ext cx="2286000" cy="365760"/>
+            <a:off x="8229600" y="6400800"/>
+            <a:ext cx="3474720" cy="365760"/>
           </a:xfrm>
           <a:prstGeom prst="rect">
             <a:avLst/>
@@ -5935,7 +5899,7 @@
         <p:spPr>
           <a:xfrm>
             <a:off x="868680" y="457200"/>
-            <a:ext cx="10607040" cy="914400"/>
+            <a:ext cx="10789920" cy="914400"/>
           </a:xfrm>
           <a:prstGeom prst="rect">
             <a:avLst/>
@@ -5968,7 +5932,7 @@
         </p:nvSpPr>
         <p:spPr>
           <a:xfrm>
-            <a:off x="960120" y="1691640"/>
+            <a:off x="960120" y="1737360"/>
             <a:ext cx="10332720" cy="4480560"/>
           </a:xfrm>
           <a:prstGeom prst="rect">
@@ -6230,7 +6194,7 @@
         <p:spPr>
           <a:xfrm>
             <a:off x="457200" y="6400800"/>
-            <a:ext cx="11247120" cy="365760"/>
+            <a:ext cx="7315200" cy="365760"/>
           </a:xfrm>
           <a:prstGeom prst="rect">
             <a:avLst/>
@@ -6243,7 +6207,6 @@
           </a:bodyPr>
           <a:lstStyle/>
           <a:p>
-            <a:pPr algn="l"/>
             <a:r>
               <a:rPr sz="1000" b="0" i="0">
                 <a:solidFill>
@@ -6264,8 +6227,8 @@
         </p:nvSpPr>
         <p:spPr>
           <a:xfrm>
-            <a:off x="9418320" y="6400800"/>
-            <a:ext cx="2286000" cy="365760"/>
+            <a:off x="8229600" y="6400800"/>
+            <a:ext cx="3474720" cy="365760"/>
           </a:xfrm>
           <a:prstGeom prst="rect">
             <a:avLst/>
@@ -6370,7 +6333,7 @@
         <p:spPr>
           <a:xfrm>
             <a:off x="868680" y="457200"/>
-            <a:ext cx="10607040" cy="914400"/>
+            <a:ext cx="10789920" cy="914400"/>
           </a:xfrm>
           <a:prstGeom prst="rect">
             <a:avLst/>
@@ -6395,16 +6358,46 @@
           </a:p>
         </p:txBody>
       </p:sp>
-      <p:sp>
-        <p:nvSpPr>
-          <p:cNvPr id="4" name="TextBox 3"/>
+      <p:pic>
+        <p:nvPicPr>
+          <p:cNvPr id="4" name="Picture 3" descr="1-langue.png"/>
+          <p:cNvPicPr>
+            <a:picLocks noChangeAspect="1"/>
+          </p:cNvPicPr>
+          <p:nvPr/>
+        </p:nvPicPr>
+        <p:blipFill>
+          <a:blip r:embed="rId2"/>
+          <a:stretch>
+            <a:fillRect/>
+          </a:stretch>
+        </p:blipFill>
+        <p:spPr>
+          <a:xfrm>
+            <a:off x="2011680" y="1371600"/>
+            <a:ext cx="3520440" cy="2288286"/>
+          </a:xfrm>
+          <a:prstGeom prst="rect">
+            <a:avLst/>
+          </a:prstGeom>
+          <a:ln w="19050">
+            <a:solidFill>
+              <a:srgbClr val="3A336B"/>
+            </a:solidFill>
+          </a:ln>
+          <a:effectLst/>
+        </p:spPr>
+      </p:pic>
+      <p:sp>
+        <p:nvSpPr>
+          <p:cNvPr id="5" name="TextBox 4"/>
           <p:cNvSpPr txBox="1"/>
           <p:nvPr/>
         </p:nvSpPr>
         <p:spPr>
           <a:xfrm>
-            <a:off x="960120" y="1691640"/>
-            <a:ext cx="10332720" cy="4480560"/>
+            <a:off x="2011680" y="3687318"/>
+            <a:ext cx="3520440" cy="292608"/>
           </a:xfrm>
           <a:prstGeom prst="rect">
             <a:avLst/>
@@ -6417,151 +6410,68 @@
           </a:bodyPr>
           <a:lstStyle/>
           <a:p>
-            <a:pPr>
-              <a:spcAft>
-                <a:spcPts val="1300"/>
-              </a:spcAft>
-            </a:pPr>
-            <a:r>
-              <a:rPr sz="2000" b="1" i="0">
+            <a:pPr algn="ctr"/>
+            <a:r>
+              <a:rPr sz="1200" b="1" i="0">
                 <a:solidFill>
                   <a:srgbClr val="A78BFA"/>
                 </a:solidFill>
                 <a:latin typeface="Calibri"/>
               </a:rPr>
-              <a:t>▸  </a:t>
-            </a:r>
-            <a:r>
-              <a:rPr sz="1900" b="0" i="0">
-                <a:solidFill>
-                  <a:srgbClr val="ECEEF8"/>
-                </a:solidFill>
-                <a:latin typeface="Calibri"/>
-              </a:rPr>
-              <a:t>Écran de choix de la langue.</a:t>
-            </a:r>
-          </a:p>
-          <a:p>
-            <a:pPr>
-              <a:spcAft>
-                <a:spcPts val="1300"/>
-              </a:spcAft>
-            </a:pPr>
-            <a:r>
-              <a:rPr sz="2000" b="1" i="0">
-                <a:solidFill>
-                  <a:srgbClr val="A78BFA"/>
-                </a:solidFill>
-                <a:latin typeface="Calibri"/>
-              </a:rPr>
-              <a:t>▸  </a:t>
-            </a:r>
-            <a:r>
-              <a:rPr sz="1900" b="0" i="0">
-                <a:solidFill>
-                  <a:srgbClr val="ECEEF8"/>
-                </a:solidFill>
-                <a:latin typeface="Calibri"/>
-              </a:rPr>
-              <a:t>Écran de connexion (nom d'utilisateur).</a:t>
-            </a:r>
-          </a:p>
-          <a:p>
-            <a:pPr>
-              <a:spcAft>
-                <a:spcPts val="1300"/>
-              </a:spcAft>
-            </a:pPr>
-            <a:r>
-              <a:rPr sz="2000" b="1" i="0">
-                <a:solidFill>
-                  <a:srgbClr val="A78BFA"/>
-                </a:solidFill>
-                <a:latin typeface="Calibri"/>
-              </a:rPr>
-              <a:t>▸  </a:t>
-            </a:r>
-            <a:r>
-              <a:rPr sz="1900" b="1" i="0">
-                <a:solidFill>
-                  <a:srgbClr val="ECEEF8"/>
-                </a:solidFill>
-                <a:latin typeface="Calibri"/>
-              </a:rPr>
-              <a:t>Écran des niveaux (avec état : </a:t>
-            </a:r>
-            <a:r>
-              <a:rPr sz="1900" b="0" i="0">
+              <a:t>1 · </a:t>
+            </a:r>
+            <a:r>
+              <a:rPr sz="1200" b="0" i="0">
                 <a:solidFill>
                   <a:srgbClr val="9AA0C8"/>
                 </a:solidFill>
                 <a:latin typeface="Calibri"/>
               </a:rPr>
-              <a:t>débloqué / verrouillé / terminé).</a:t>
-            </a:r>
-          </a:p>
-          <a:p>
-            <a:pPr>
-              <a:spcAft>
-                <a:spcPts val="1300"/>
-              </a:spcAft>
-            </a:pPr>
-            <a:r>
-              <a:rPr sz="2000" b="1" i="0">
-                <a:solidFill>
-                  <a:srgbClr val="A78BFA"/>
-                </a:solidFill>
-                <a:latin typeface="Calibri"/>
-              </a:rPr>
-              <a:t>▸  </a:t>
-            </a:r>
-            <a:r>
-              <a:rPr sz="1900" b="0" i="0">
-                <a:solidFill>
-                  <a:srgbClr val="ECEEF8"/>
-                </a:solidFill>
-                <a:latin typeface="Calibri"/>
-              </a:rPr>
-              <a:t>Écran du quiz (question, réponses, minuteur, score).</a:t>
-            </a:r>
-          </a:p>
-          <a:p>
-            <a:pPr>
-              <a:spcAft>
-                <a:spcPts val="1300"/>
-              </a:spcAft>
-            </a:pPr>
-            <a:r>
-              <a:rPr sz="2000" b="1" i="0">
-                <a:solidFill>
-                  <a:srgbClr val="A78BFA"/>
-                </a:solidFill>
-                <a:latin typeface="Calibri"/>
-              </a:rPr>
-              <a:t>▸  </a:t>
-            </a:r>
-            <a:r>
-              <a:rPr sz="1900" b="0" i="0">
-                <a:solidFill>
-                  <a:srgbClr val="ECEEF8"/>
-                </a:solidFill>
-                <a:latin typeface="Calibri"/>
-              </a:rPr>
-              <a:t>Écran de résultat (score, étoiles, navigation).</a:t>
-            </a:r>
-          </a:p>
-        </p:txBody>
-      </p:sp>
-      <p:sp>
-        <p:nvSpPr>
-          <p:cNvPr id="5" name="TextBox 4"/>
+              <a:t>Choix de la langue</a:t>
+            </a:r>
+          </a:p>
+        </p:txBody>
+      </p:sp>
+      <p:pic>
+        <p:nvPicPr>
+          <p:cNvPr id="6" name="Picture 5" descr="2-niveaux.png"/>
+          <p:cNvPicPr>
+            <a:picLocks noChangeAspect="1"/>
+          </p:cNvPicPr>
+          <p:nvPr/>
+        </p:nvPicPr>
+        <p:blipFill>
+          <a:blip r:embed="rId3"/>
+          <a:stretch>
+            <a:fillRect/>
+          </a:stretch>
+        </p:blipFill>
+        <p:spPr>
+          <a:xfrm>
+            <a:off x="6675120" y="1371600"/>
+            <a:ext cx="3520440" cy="2288286"/>
+          </a:xfrm>
+          <a:prstGeom prst="rect">
+            <a:avLst/>
+          </a:prstGeom>
+          <a:ln w="19050">
+            <a:solidFill>
+              <a:srgbClr val="3A336B"/>
+            </a:solidFill>
+          </a:ln>
+          <a:effectLst/>
+        </p:spPr>
+      </p:pic>
+      <p:sp>
+        <p:nvSpPr>
+          <p:cNvPr id="7" name="TextBox 6"/>
           <p:cNvSpPr txBox="1"/>
           <p:nvPr/>
         </p:nvSpPr>
         <p:spPr>
           <a:xfrm>
-            <a:off x="457200" y="6400800"/>
-            <a:ext cx="11247120" cy="365760"/>
+            <a:off x="6675120" y="3687318"/>
+            <a:ext cx="3520440" cy="292608"/>
           </a:xfrm>
           <a:prstGeom prst="rect">
             <a:avLst/>
@@ -6574,29 +6484,220 @@
           </a:bodyPr>
           <a:lstStyle/>
           <a:p>
-            <a:pPr algn="l"/>
-            <a:r>
-              <a:rPr sz="1000" b="0" i="0">
+            <a:pPr algn="ctr"/>
+            <a:r>
+              <a:rPr sz="1200" b="1" i="0">
+                <a:solidFill>
+                  <a:srgbClr val="A78BFA"/>
+                </a:solidFill>
+                <a:latin typeface="Calibri"/>
+              </a:rPr>
+              <a:t>2 · </a:t>
+            </a:r>
+            <a:r>
+              <a:rPr sz="1200" b="0" i="0">
                 <a:solidFill>
                   <a:srgbClr val="9AA0C8"/>
                 </a:solidFill>
                 <a:latin typeface="Calibri"/>
               </a:rPr>
-              <a:t>ISMAGI Quiz Game</a:t>
-            </a:r>
-          </a:p>
-        </p:txBody>
-      </p:sp>
-      <p:sp>
-        <p:nvSpPr>
-          <p:cNvPr id="6" name="TextBox 5"/>
+              <a:t>Menu des niveaux</a:t>
+            </a:r>
+          </a:p>
+        </p:txBody>
+      </p:sp>
+      <p:pic>
+        <p:nvPicPr>
+          <p:cNvPr id="8" name="Picture 7" descr="3-quiz.png"/>
+          <p:cNvPicPr>
+            <a:picLocks noChangeAspect="1"/>
+          </p:cNvPicPr>
+          <p:nvPr/>
+        </p:nvPicPr>
+        <p:blipFill>
+          <a:blip r:embed="rId4"/>
+          <a:stretch>
+            <a:fillRect/>
+          </a:stretch>
+        </p:blipFill>
+        <p:spPr>
+          <a:xfrm>
+            <a:off x="2011680" y="4114800"/>
+            <a:ext cx="3520440" cy="2288286"/>
+          </a:xfrm>
+          <a:prstGeom prst="rect">
+            <a:avLst/>
+          </a:prstGeom>
+          <a:ln w="19050">
+            <a:solidFill>
+              <a:srgbClr val="3A336B"/>
+            </a:solidFill>
+          </a:ln>
+          <a:effectLst/>
+        </p:spPr>
+      </p:pic>
+      <p:sp>
+        <p:nvSpPr>
+          <p:cNvPr id="9" name="TextBox 8"/>
           <p:cNvSpPr txBox="1"/>
           <p:nvPr/>
         </p:nvSpPr>
         <p:spPr>
           <a:xfrm>
-            <a:off x="9418320" y="6400800"/>
-            <a:ext cx="2286000" cy="365760"/>
+            <a:off x="2011680" y="6430518"/>
+            <a:ext cx="3520440" cy="292608"/>
+          </a:xfrm>
+          <a:prstGeom prst="rect">
+            <a:avLst/>
+          </a:prstGeom>
+          <a:noFill/>
+        </p:spPr>
+        <p:txBody>
+          <a:bodyPr wrap="square">
+            <a:spAutoFit/>
+          </a:bodyPr>
+          <a:lstStyle/>
+          <a:p>
+            <a:pPr algn="ctr"/>
+            <a:r>
+              <a:rPr sz="1200" b="1" i="0">
+                <a:solidFill>
+                  <a:srgbClr val="A78BFA"/>
+                </a:solidFill>
+                <a:latin typeface="Calibri"/>
+              </a:rPr>
+              <a:t>3 · </a:t>
+            </a:r>
+            <a:r>
+              <a:rPr sz="1200" b="0" i="0">
+                <a:solidFill>
+                  <a:srgbClr val="9AA0C8"/>
+                </a:solidFill>
+                <a:latin typeface="Calibri"/>
+              </a:rPr>
+              <a:t>Question du quiz</a:t>
+            </a:r>
+          </a:p>
+        </p:txBody>
+      </p:sp>
+      <p:pic>
+        <p:nvPicPr>
+          <p:cNvPr id="10" name="Picture 9" descr="4-resultat.png"/>
+          <p:cNvPicPr>
+            <a:picLocks noChangeAspect="1"/>
+          </p:cNvPicPr>
+          <p:nvPr/>
+        </p:nvPicPr>
+        <p:blipFill>
+          <a:blip r:embed="rId5"/>
+          <a:stretch>
+            <a:fillRect/>
+          </a:stretch>
+        </p:blipFill>
+        <p:spPr>
+          <a:xfrm>
+            <a:off x="6675120" y="4114800"/>
+            <a:ext cx="3520440" cy="2288286"/>
+          </a:xfrm>
+          <a:prstGeom prst="rect">
+            <a:avLst/>
+          </a:prstGeom>
+          <a:ln w="19050">
+            <a:solidFill>
+              <a:srgbClr val="3A336B"/>
+            </a:solidFill>
+          </a:ln>
+          <a:effectLst/>
+        </p:spPr>
+      </p:pic>
+      <p:sp>
+        <p:nvSpPr>
+          <p:cNvPr id="11" name="TextBox 10"/>
+          <p:cNvSpPr txBox="1"/>
+          <p:nvPr/>
+        </p:nvSpPr>
+        <p:spPr>
+          <a:xfrm>
+            <a:off x="6675120" y="6430518"/>
+            <a:ext cx="3520440" cy="292608"/>
+          </a:xfrm>
+          <a:prstGeom prst="rect">
+            <a:avLst/>
+          </a:prstGeom>
+          <a:noFill/>
+        </p:spPr>
+        <p:txBody>
+          <a:bodyPr wrap="square">
+            <a:spAutoFit/>
+          </a:bodyPr>
+          <a:lstStyle/>
+          <a:p>
+            <a:pPr algn="ctr"/>
+            <a:r>
+              <a:rPr sz="1200" b="1" i="0">
+                <a:solidFill>
+                  <a:srgbClr val="A78BFA"/>
+                </a:solidFill>
+                <a:latin typeface="Calibri"/>
+              </a:rPr>
+              <a:t>4 · </a:t>
+            </a:r>
+            <a:r>
+              <a:rPr sz="1200" b="0" i="0">
+                <a:solidFill>
+                  <a:srgbClr val="9AA0C8"/>
+                </a:solidFill>
+                <a:latin typeface="Calibri"/>
+              </a:rPr>
+              <a:t>Écran de résultat</a:t>
+            </a:r>
+          </a:p>
+        </p:txBody>
+      </p:sp>
+      <p:sp>
+        <p:nvSpPr>
+          <p:cNvPr id="12" name="TextBox 11"/>
+          <p:cNvSpPr txBox="1"/>
+          <p:nvPr/>
+        </p:nvSpPr>
+        <p:spPr>
+          <a:xfrm>
+            <a:off x="457200" y="6400800"/>
+            <a:ext cx="7315200" cy="365760"/>
+          </a:xfrm>
+          <a:prstGeom prst="rect">
+            <a:avLst/>
+          </a:prstGeom>
+          <a:noFill/>
+        </p:spPr>
+        <p:txBody>
+          <a:bodyPr wrap="square">
+            <a:spAutoFit/>
+          </a:bodyPr>
+          <a:lstStyle/>
+          <a:p>
+            <a:r>
+              <a:rPr sz="1000" b="0" i="0">
+                <a:solidFill>
+                  <a:srgbClr val="9AA0C8"/>
+                </a:solidFill>
+                <a:latin typeface="Calibri"/>
+              </a:rPr>
+              <a:t>ISMAGI Quiz Game</a:t>
+            </a:r>
+          </a:p>
+        </p:txBody>
+      </p:sp>
+      <p:sp>
+        <p:nvSpPr>
+          <p:cNvPr id="13" name="TextBox 12"/>
+          <p:cNvSpPr txBox="1"/>
+          <p:nvPr/>
+        </p:nvSpPr>
+        <p:spPr>
+          <a:xfrm>
+            <a:off x="8229600" y="6400800"/>
+            <a:ext cx="3474720" cy="365760"/>
           </a:xfrm>
           <a:prstGeom prst="rect">
             <a:avLst/>
@@ -6701,7 +6802,7 @@
         <p:spPr>
           <a:xfrm>
             <a:off x="868680" y="457200"/>
-            <a:ext cx="10607040" cy="914400"/>
+            <a:ext cx="10789920" cy="914400"/>
           </a:xfrm>
           <a:prstGeom prst="rect">
             <a:avLst/>
@@ -6734,7 +6835,7 @@
         </p:nvSpPr>
         <p:spPr>
           <a:xfrm>
-            <a:off x="960120" y="1691640"/>
+            <a:off x="960120" y="1737360"/>
             <a:ext cx="10332720" cy="4480560"/>
           </a:xfrm>
           <a:prstGeom prst="rect">
@@ -6928,7 +7029,7 @@
         <p:spPr>
           <a:xfrm>
             <a:off x="457200" y="6400800"/>
-            <a:ext cx="11247120" cy="365760"/>
+            <a:ext cx="7315200" cy="365760"/>
           </a:xfrm>
           <a:prstGeom prst="rect">
             <a:avLst/>
@@ -6941,7 +7042,6 @@
           </a:bodyPr>
           <a:lstStyle/>
           <a:p>
-            <a:pPr algn="l"/>
             <a:r>
               <a:rPr sz="1000" b="0" i="0">
                 <a:solidFill>
@@ -6962,8 +7062,8 @@
         </p:nvSpPr>
         <p:spPr>
           <a:xfrm>
-            <a:off x="9418320" y="6400800"/>
-            <a:ext cx="2286000" cy="365760"/>
+            <a:off x="8229600" y="6400800"/>
+            <a:ext cx="3474720" cy="365760"/>
           </a:xfrm>
           <a:prstGeom prst="rect">
             <a:avLst/>
@@ -7068,7 +7168,7 @@
         <p:spPr>
           <a:xfrm>
             <a:off x="868680" y="457200"/>
-            <a:ext cx="10607040" cy="914400"/>
+            <a:ext cx="10789920" cy="914400"/>
           </a:xfrm>
           <a:prstGeom prst="rect">
             <a:avLst/>
@@ -7101,7 +7201,7 @@
         </p:nvSpPr>
         <p:spPr>
           <a:xfrm>
-            <a:off x="960120" y="1691640"/>
+            <a:off x="960120" y="1737360"/>
             <a:ext cx="10332720" cy="4480560"/>
           </a:xfrm>
           <a:prstGeom prst="rect">
@@ -7261,7 +7361,7 @@
         <p:spPr>
           <a:xfrm>
             <a:off x="457200" y="6400800"/>
-            <a:ext cx="11247120" cy="365760"/>
+            <a:ext cx="7315200" cy="365760"/>
           </a:xfrm>
           <a:prstGeom prst="rect">
             <a:avLst/>
@@ -7274,7 +7374,6 @@
           </a:bodyPr>
           <a:lstStyle/>
           <a:p>
-            <a:pPr algn="l"/>
             <a:r>
               <a:rPr sz="1000" b="0" i="0">
                 <a:solidFill>
@@ -7295,8 +7394,8 @@
         </p:nvSpPr>
         <p:spPr>
           <a:xfrm>
-            <a:off x="9418320" y="6400800"/>
-            <a:ext cx="2286000" cy="365760"/>
+            <a:off x="8229600" y="6400800"/>
+            <a:ext cx="3474720" cy="365760"/>
           </a:xfrm>
           <a:prstGeom prst="rect">
             <a:avLst/>

</xml_diff>